<commit_message>
Replace CSL URLs with local copies and regenerate artifacts
- Added local CSL files: chicago-note-bibliography.csl and chicago-author-date.csl
- Updated article/article.md, thesis/00.md, presentation/presentation.md, and README.md to use local CSL paths
- Fixed pandoc-crossref download URL in pandoc.yml workflow
- Regenerated all build artifacts (docx, pdf, tex, epub, pptx, html)

Co-authored-by: maehr <14755525+maehr@users.noreply.github.com>
</commit_message>
<xml_diff>
--- a/presentation/presentation.pptx
+++ b/presentation/presentation.pptx
@@ -3933,7 +3933,9 @@
         <p:nvSpPr>
           <p:cNvPr id="1" name="TextBox 3"/>
           <p:cNvSpPr txBox="1"/>
-          <p:nvPr/>
+          <p:nvPr>
+            <p:ph idx="1"/>
+          </p:nvPr>
         </p:nvSpPr>
         <p:spPr>
           <a:xfrm>
@@ -4381,7 +4383,9 @@
         <p:nvSpPr>
           <p:cNvPr id="1" name="TextBox 3"/>
           <p:cNvSpPr txBox="1"/>
-          <p:nvPr/>
+          <p:nvPr>
+            <p:ph idx="1"/>
+          </p:nvPr>
         </p:nvSpPr>
         <p:spPr>
           <a:xfrm>
@@ -5586,7 +5590,7 @@
             </a:r>
             <a:r>
               <a:rPr/>
-              <a:t>. Cambridge, [New York]: Open Book Publishers ; NYU Global Institute for Advanced Study.</a:t>
+              <a:t>. Open Book Publishers ; NYU Global Institute for Advanced Study.</a:t>
             </a:r>
           </a:p>
           <a:p>

</xml_diff>

<commit_message>
chore: render quarto artifacts
</commit_message>
<xml_diff>
--- a/presentation/presentation.pptx
+++ b/presentation/presentation.pptx
@@ -3633,16 +3633,12 @@
             <a:br/>
             <a:br/>
             <a:r>
-              <a:rPr>
-                <a:hlinkClick r:id="rId2"/>
-              </a:rPr>
+              <a:rPr/>
               <a:t>Eleanor Roosevelt</a:t>
             </a:r>
             <a:br/>
             <a:r>
-              <a:rPr>
-                <a:hlinkClick r:id="rId3"/>
-              </a:rPr>
+              <a:rPr/>
               <a:t>John Peters Humphrey</a:t>
             </a:r>
           </a:p>
@@ -3668,7 +3664,7 @@
             </a:pPr>
             <a:r>
               <a:rPr/>
-              <a:t>1 January 2023</a:t>
+              <a:t>2023-01-01</a:t>
             </a:r>
           </a:p>
         </p:txBody>
@@ -4041,13 +4037,13 @@
                 <a:solidFill>
                   <a:srgbClr val="06287E"/>
                 </a:solidFill>
-                <a:latin typeface=""/>
+                <a:latin typeface="Courier"/>
               </a:rPr>
               <a:t>ping</a:t>
             </a:r>
             <a:r>
               <a:rPr>
-                <a:latin typeface=""/>
+                <a:latin typeface="Courier"/>
               </a:rPr>
               <a:t> wikipedia.org</a:t>
             </a:r>

</xml_diff>